<commit_message>
Changed date on the presentation
</commit_message>
<xml_diff>
--- a/Project book & presentation/Fruit_Grading_Presentation.pptx
+++ b/Project book & presentation/Fruit_Grading_Presentation.pptx
@@ -2189,7 +2189,29 @@
                 <a:ea typeface="Calibri" pitchFamily="34" charset="-122"/>
                 <a:cs typeface="Calibri" pitchFamily="34" charset="-120"/>
               </a:rPr>
-              <a:t>Project Code: 26-1-D-32  |  Capstone Phase B  |  January 2026</a:t>
+              <a:t>Project Code: 26-1-D-32  |  Capstone Phase B  </a:t>
+            </a:r>
+            <a:r>
+              <a:rPr lang="en-US" sz="1100">
+                <a:solidFill>
+                  <a:srgbClr val="D4A017"/>
+                </a:solidFill>
+                <a:latin typeface="Calibri" pitchFamily="34" charset="0"/>
+                <a:ea typeface="Calibri" pitchFamily="34" charset="-122"/>
+                <a:cs typeface="Calibri" pitchFamily="34" charset="-120"/>
+              </a:rPr>
+              <a:t>|  March </a:t>
+            </a:r>
+            <a:r>
+              <a:rPr lang="en-US" sz="1100" dirty="0">
+                <a:solidFill>
+                  <a:srgbClr val="D4A017"/>
+                </a:solidFill>
+                <a:latin typeface="Calibri" pitchFamily="34" charset="0"/>
+                <a:ea typeface="Calibri" pitchFamily="34" charset="-122"/>
+                <a:cs typeface="Calibri" pitchFamily="34" charset="-120"/>
+              </a:rPr>
+              <a:t>2026</a:t>
             </a:r>
             <a:endParaRPr lang="en-US" sz="1600" dirty="0"/>
           </a:p>

</xml_diff>

<commit_message>
Changed the presentation (Specificity)
</commit_message>
<xml_diff>
--- a/Project book & presentation/Fruit_Grading_Presentation.pptx
+++ b/Project book & presentation/Fruit_Grading_Presentation.pptx
@@ -126,6 +126,50 @@
     </p:ext>
   </p:extLst>
 </p:presentation>
+</file>
+
+<file path=ppt/changesInfos/changesInfo1.xml><?xml version="1.0" encoding="utf-8"?>
+<pc:chgInfo xmlns:a="http://schemas.openxmlformats.org/drawingml/2006/main" xmlns:r="http://schemas.openxmlformats.org/officeDocument/2006/relationships" xmlns:ac="http://schemas.microsoft.com/office/drawing/2013/main/command" xmlns:pc="http://schemas.microsoft.com/office/powerpoint/2013/main/command">
+  <pc:docChgLst>
+    <pc:chgData name="Lidor Anfinger" userId="83fa358e1e6a7b02" providerId="LiveId" clId="{E7E73950-2C38-4607-8B27-A967845F8A9C}"/>
+    <pc:docChg chg="custSel modSld">
+      <pc:chgData name="Lidor Anfinger" userId="83fa358e1e6a7b02" providerId="LiveId" clId="{E7E73950-2C38-4607-8B27-A967845F8A9C}" dt="2026-03-15T18:15:11.278" v="15" actId="20577"/>
+      <pc:docMkLst>
+        <pc:docMk/>
+      </pc:docMkLst>
+      <pc:sldChg chg="modSp mod">
+        <pc:chgData name="Lidor Anfinger" userId="83fa358e1e6a7b02" providerId="LiveId" clId="{E7E73950-2C38-4607-8B27-A967845F8A9C}" dt="2026-03-15T18:15:11.278" v="15" actId="20577"/>
+        <pc:sldMkLst>
+          <pc:docMk/>
+          <pc:sldMk cId="0" sldId="260"/>
+        </pc:sldMkLst>
+        <pc:spChg chg="mod">
+          <ac:chgData name="Lidor Anfinger" userId="83fa358e1e6a7b02" providerId="LiveId" clId="{E7E73950-2C38-4607-8B27-A967845F8A9C}" dt="2026-03-15T18:15:11.278" v="15" actId="20577"/>
+          <ac:spMkLst>
+            <pc:docMk/>
+            <pc:sldMk cId="0" sldId="260"/>
+            <ac:spMk id="13" creationId="{00000000-0000-0000-0000-000000000000}"/>
+          </ac:spMkLst>
+        </pc:spChg>
+      </pc:sldChg>
+      <pc:sldChg chg="modSp mod">
+        <pc:chgData name="Lidor Anfinger" userId="83fa358e1e6a7b02" providerId="LiveId" clId="{E7E73950-2C38-4607-8B27-A967845F8A9C}" dt="2026-03-15T17:48:44.226" v="14" actId="113"/>
+        <pc:sldMkLst>
+          <pc:docMk/>
+          <pc:sldMk cId="0" sldId="265"/>
+        </pc:sldMkLst>
+        <pc:graphicFrameChg chg="modGraphic">
+          <ac:chgData name="Lidor Anfinger" userId="83fa358e1e6a7b02" providerId="LiveId" clId="{E7E73950-2C38-4607-8B27-A967845F8A9C}" dt="2026-03-15T17:48:44.226" v="14" actId="113"/>
+          <ac:graphicFrameMkLst>
+            <pc:docMk/>
+            <pc:sldMk cId="0" sldId="265"/>
+            <ac:graphicFrameMk id="27" creationId="{00000000-0000-0000-0000-000000000000}"/>
+          </ac:graphicFrameMkLst>
+        </pc:graphicFrameChg>
+      </pc:sldChg>
+    </pc:docChg>
+  </pc:docChgLst>
+</pc:chgInfo>
 </file>
 
 <file path=ppt/notesMasters/notesMaster1.xml><?xml version="1.0" encoding="utf-8"?>
@@ -5352,7 +5396,7 @@
           <p:nvPr>
             <p:extLst>
               <p:ext uri="{D42A27DB-BD31-4B8C-83A1-F6EECF244321}">
-                <p14:modId xmlns:p14="http://schemas.microsoft.com/office/powerpoint/2010/main" val="1579011935"/>
+                <p14:modId xmlns:p14="http://schemas.microsoft.com/office/powerpoint/2010/main" val="2453512242"/>
               </p:ext>
             </p:extLst>
           </p:nvPr>
@@ -5712,7 +5756,7 @@
                             <a:srgbClr val="333333"/>
                           </a:solidFill>
                         </a:rPr>
-                        <a:t>80%</a:t>
+                        <a:t>83.3%</a:t>
                       </a:r>
                       <a:endParaRPr lang="en-US" sz="1100" dirty="0"/>
                     </a:p>
@@ -5891,14 +5935,13 @@
                         <a:buNone/>
                       </a:pPr>
                       <a:r>
-                        <a:rPr lang="en-US" sz="1100" b="1" dirty="0">
+                        <a:rPr lang="en-US" sz="1100" b="0" dirty="0">
                           <a:solidFill>
-                            <a:srgbClr val="2E7D32"/>
+                            <a:schemeClr val="tx1"/>
                           </a:solidFill>
                         </a:rPr>
-                        <a:t>100%</a:t>
+                        <a:t>85.7%</a:t>
                       </a:r>
-                      <a:endParaRPr lang="en-US" sz="1100" dirty="0"/>
                     </a:p>
                   </a:txBody>
                   <a:tcPr anchor="ctr">
@@ -6017,14 +6060,13 @@
                         <a:buNone/>
                       </a:pPr>
                       <a:r>
-                        <a:rPr lang="en-US" sz="1100" b="1" dirty="0">
+                        <a:rPr lang="en-US" sz="1100" b="0" dirty="0">
                           <a:solidFill>
-                            <a:srgbClr val="C62828"/>
+                            <a:schemeClr val="tx1"/>
                           </a:solidFill>
                         </a:rPr>
                         <a:t>33.3%</a:t>
                       </a:r>
-                      <a:endParaRPr lang="en-US" sz="1100" dirty="0"/>
                     </a:p>
                   </a:txBody>
                   <a:tcPr anchor="ctr">
@@ -14576,27 +14618,6 @@
             </a:r>
             <a:endParaRPr lang="en-US" sz="1200" dirty="0"/>
           </a:p>
-          <a:p>
-            <a:pPr marL="342900" indent="-342900">
-              <a:spcAft>
-                <a:spcPts val="400"/>
-              </a:spcAft>
-              <a:buSzPct val="100000"/>
-              <a:buChar char="•"/>
-            </a:pPr>
-            <a:r>
-              <a:rPr lang="en-US" sz="1200" dirty="0">
-                <a:solidFill>
-                  <a:srgbClr val="333333"/>
-                </a:solidFill>
-                <a:latin typeface="Calibri" pitchFamily="34" charset="0"/>
-                <a:ea typeface="Calibri" pitchFamily="34" charset="-122"/>
-                <a:cs typeface="Calibri" pitchFamily="34" charset="-120"/>
-              </a:rPr>
-              <a:t>Responsive design</a:t>
-            </a:r>
-            <a:endParaRPr lang="en-US" sz="1200" dirty="0"/>
-          </a:p>
         </p:txBody>
       </p:sp>
       <p:sp>

</xml_diff>